<commit_message>
docs(business-model): refresh BM + BMC for partner spaces (Kit Digital) & P1–P5
- business-model.md: add Ligne 7 « Espaces partenaires (Kit Digital) » (modèle
  hybride: palier ~49–99k XOF/mois + Pacte-Convention sur devis) across A.1/A.2/A.3;
  flywheel partner accelerator (A.4); scorecard 7→8 (A.7); P1–P5 implementation
  status; formations explicitly non-monétisées (acquisition lever)
- business-pdf.mjs + bmc-pptx.mjs: aligned BMC (9 blocks) + revenue line, unit-econ
  tables, scorecard, snapshot, roadmap, état d'implémentation
- regenerate docs/business-model.pdf + docs/business-model-canvas.pptx

Co-Authored-By: Claude Opus 4.8 (1M context) <noreply@anthropic.com>
</commit_message>
<xml_diff>
--- a/docs/business-model-canvas.pptx
+++ b/docs/business-model-canvas.pptx
@@ -2593,7 +2593,7 @@
                   <a:srgbClr val="0B1F49"/>
                 </a:solidFill>
               </a:rPr>
-              <a:t>Partenaires / ONG / institutions / bailleurs</a:t>
+              <a:t>Partenaires communautaires &amp; associatifs (ASSAD)</a:t>
             </a:r>
             <a:endParaRPr lang="en-US" sz="1600" dirty="0"/>
           </a:p>
@@ -2614,7 +2614,7 @@
                   <a:srgbClr val="0B1F49"/>
                 </a:solidFill>
               </a:rPr>
-              <a:t>Organisateurs d'événements santé</a:t>
+              <a:t>Institutions &amp; bailleurs (impact / ESG)</a:t>
             </a:r>
             <a:endParaRPr lang="en-US" sz="1600" dirty="0"/>
           </a:p>
@@ -2635,7 +2635,7 @@
                   <a:srgbClr val="0B1F49"/>
                 </a:solidFill>
               </a:rPr>
-              <a:t>Soignants (forum, contenu)</a:t>
+              <a:t>Académiques &amp; formation · soignants vérifiés · organisateurs</a:t>
             </a:r>
             <a:endParaRPr lang="en-US" sz="1600" dirty="0"/>
           </a:p>
@@ -2954,7 +2954,7 @@
                   <a:srgbClr val="0B1F49"/>
                 </a:solidFill>
               </a:rPr>
-              <a:t>Production éditoriale &amp; modération</a:t>
+              <a:t>Coûts SMS / WhatsApp (templates Meta, agrégateur)</a:t>
             </a:r>
             <a:endParaRPr lang="en-US" sz="1600" dirty="0"/>
           </a:p>
@@ -2975,7 +2975,7 @@
                   <a:srgbClr val="0B1F49"/>
                 </a:solidFill>
               </a:rPr>
-              <a:t>Acquisition marketing (ads ciblées)</a:t>
+              <a:t>Provisioning DNS / SSL multi-tenant</a:t>
             </a:r>
             <a:endParaRPr lang="en-US" sz="1600" dirty="0"/>
           </a:p>
@@ -2996,7 +2996,7 @@
                   <a:srgbClr val="0B1F49"/>
                 </a:solidFill>
               </a:rPr>
-              <a:t>Équipe &amp; exploitation</a:t>
+              <a:t>Production éditoriale &amp; modération · acquisition</a:t>
             </a:r>
             <a:endParaRPr lang="en-US" sz="1600" dirty="0"/>
           </a:p>
@@ -3017,7 +3017,7 @@
                   <a:srgbClr val="0B1F49"/>
                 </a:solidFill>
               </a:rPr>
-              <a:t>Conformité (TVA, protection des données / CDP)</a:t>
+              <a:t>Équipe &amp; exploitation · conformité (TVA, CDP)</a:t>
             </a:r>
             <a:endParaRPr lang="en-US" sz="1600" dirty="0"/>
           </a:p>
@@ -3294,7 +3294,7 @@
                   <a:srgbClr val="0B1F49"/>
                 </a:solidFill>
               </a:rPr>
-              <a:t>Dons + pourboire plateforme optionnel (+ récurrents)</a:t>
+              <a:t>Dons + pourboire plateforme optionnel (+ dons récurrents)</a:t>
             </a:r>
             <a:endParaRPr lang="en-US" sz="1600" dirty="0"/>
           </a:p>
@@ -3316,6 +3316,27 @@
                 </a:solidFill>
               </a:rPr>
               <a:t>Abonnements pages : Vérifié 9 900 / Pro 24 900 XOF / mois (−20 % annuel)</a:t>
+            </a:r>
+            <a:endParaRPr lang="en-US" sz="1600" dirty="0"/>
+          </a:p>
+          <a:p>
+            <a:pPr marL="152400" indent="-152400">
+              <a:lnSpc>
+                <a:spcPct val="110000"/>
+              </a:lnSpc>
+              <a:spcAft>
+                <a:spcPts val="1000"/>
+              </a:spcAft>
+              <a:buSzPct val="100000"/>
+              <a:buChar char="•"/>
+            </a:pPr>
+            <a:r>
+              <a:rPr lang="en-US" sz="1600" dirty="0">
+                <a:solidFill>
+                  <a:srgbClr val="0B1F49"/>
+                </a:solidFill>
+              </a:rPr>
+              <a:t>Espaces partenaires (Kit Digital) : ~49–99 k XOF/mois + Pacte-Convention annuel sur devis</a:t>
             </a:r>
             <a:endParaRPr lang="en-US" sz="1600" dirty="0"/>
           </a:p>
@@ -3603,14 +3624,14 @@
             <a:tbl>
               <a:tblPr/>
               <a:tblGrid>
-                <a:gridCol w="1828800"/>
+                <a:gridCol w="2011680"/>
                 <a:gridCol w="2377440"/>
                 <a:gridCol w="1463040"/>
-                <a:gridCol w="3017520"/>
+                <a:gridCol w="2834640"/>
                 <a:gridCol w="1280160"/>
                 <a:gridCol w="1280160"/>
               </a:tblGrid>
-              <a:tr h="502920">
+              <a:tr h="457200">
                 <a:tc>
                   <a:txBody>
                     <a:bodyPr/>
@@ -3978,7 +3999,7 @@
                   </a:tcPr>
                 </a:tc>
               </a:tr>
-              <a:tr h="502920">
+              <a:tr h="457200">
                 <a:tc>
                   <a:txBody>
                     <a:bodyPr/>
@@ -4346,7 +4367,7 @@
                   </a:tcPr>
                 </a:tc>
               </a:tr>
-              <a:tr h="502920">
+              <a:tr h="457200">
                 <a:tc>
                   <a:txBody>
                     <a:bodyPr/>
@@ -4714,7 +4735,375 @@
                   </a:tcPr>
                 </a:tc>
               </a:tr>
-              <a:tr h="502920">
+              <a:tr h="457200">
+                <a:tc>
+                  <a:txBody>
+                    <a:bodyPr/>
+                    <a:lstStyle/>
+                    <a:p>
+                      <a:pPr algn="l" indent="0" marL="0">
+                        <a:buNone/>
+                      </a:pPr>
+                      <a:r>
+                        <a:rPr lang="en-US" sz="1100" dirty="0">
+                          <a:solidFill>
+                            <a:srgbClr val="0B1F49"/>
+                          </a:solidFill>
+                        </a:rPr>
+                        <a:t>Espaces partenaires (Kit)</a:t>
+                      </a:r>
+                      <a:endParaRPr lang="en-US" sz="1100" dirty="0"/>
+                    </a:p>
+                  </a:txBody>
+                  <a:tcPr marL="91440" marR="91440" marT="45720" marB="45720" anchor="ctr">
+                    <a:lnL w="12700" cap="flat" cmpd="sng" algn="ctr">
+                      <a:solidFill>
+                        <a:srgbClr val="E6EEF2"/>
+                      </a:solidFill>
+                      <a:prstDash val="solid"/>
+                      <a:round/>
+                      <a:headEnd type="none" w="med" len="med"/>
+                      <a:tailEnd type="none" w="med" len="med"/>
+                    </a:lnL>
+                    <a:lnR w="12700" cap="flat" cmpd="sng" algn="ctr">
+                      <a:solidFill>
+                        <a:srgbClr val="E6EEF2"/>
+                      </a:solidFill>
+                      <a:prstDash val="solid"/>
+                      <a:round/>
+                      <a:headEnd type="none" w="med" len="med"/>
+                      <a:tailEnd type="none" w="med" len="med"/>
+                    </a:lnR>
+                    <a:lnT w="12700" cap="flat" cmpd="sng" algn="ctr">
+                      <a:solidFill>
+                        <a:srgbClr val="E6EEF2"/>
+                      </a:solidFill>
+                      <a:prstDash val="solid"/>
+                      <a:round/>
+                      <a:headEnd type="none" w="med" len="med"/>
+                      <a:tailEnd type="none" w="med" len="med"/>
+                    </a:lnT>
+                    <a:lnB w="12700" cap="flat" cmpd="sng" algn="ctr">
+                      <a:solidFill>
+                        <a:srgbClr val="E6EEF2"/>
+                      </a:solidFill>
+                      <a:prstDash val="solid"/>
+                      <a:round/>
+                      <a:headEnd type="none" w="med" len="med"/>
+                      <a:tailEnd type="none" w="med" len="med"/>
+                    </a:lnB>
+                    <a:solidFill>
+                      <a:srgbClr val="F7FBFA"/>
+                    </a:solidFill>
+                  </a:tcPr>
+                </a:tc>
+                <a:tc>
+                  <a:txBody>
+                    <a:bodyPr/>
+                    <a:lstStyle/>
+                    <a:p>
+                      <a:pPr algn="l" indent="0" marL="0">
+                        <a:buNone/>
+                      </a:pPr>
+                      <a:r>
+                        <a:rPr lang="en-US" sz="1100" dirty="0">
+                          <a:solidFill>
+                            <a:srgbClr val="0B1F49"/>
+                          </a:solidFill>
+                        </a:rPr>
+                        <a:t>Hybride abo + convention</a:t>
+                      </a:r>
+                      <a:endParaRPr lang="en-US" sz="1100" dirty="0"/>
+                    </a:p>
+                  </a:txBody>
+                  <a:tcPr marL="91440" marR="91440" marT="45720" marB="45720" anchor="ctr">
+                    <a:lnL w="12700" cap="flat" cmpd="sng" algn="ctr">
+                      <a:solidFill>
+                        <a:srgbClr val="E6EEF2"/>
+                      </a:solidFill>
+                      <a:prstDash val="solid"/>
+                      <a:round/>
+                      <a:headEnd type="none" w="med" len="med"/>
+                      <a:tailEnd type="none" w="med" len="med"/>
+                    </a:lnL>
+                    <a:lnR w="12700" cap="flat" cmpd="sng" algn="ctr">
+                      <a:solidFill>
+                        <a:srgbClr val="E6EEF2"/>
+                      </a:solidFill>
+                      <a:prstDash val="solid"/>
+                      <a:round/>
+                      <a:headEnd type="none" w="med" len="med"/>
+                      <a:tailEnd type="none" w="med" len="med"/>
+                    </a:lnR>
+                    <a:lnT w="12700" cap="flat" cmpd="sng" algn="ctr">
+                      <a:solidFill>
+                        <a:srgbClr val="E6EEF2"/>
+                      </a:solidFill>
+                      <a:prstDash val="solid"/>
+                      <a:round/>
+                      <a:headEnd type="none" w="med" len="med"/>
+                      <a:tailEnd type="none" w="med" len="med"/>
+                    </a:lnT>
+                    <a:lnB w="12700" cap="flat" cmpd="sng" algn="ctr">
+                      <a:solidFill>
+                        <a:srgbClr val="E6EEF2"/>
+                      </a:solidFill>
+                      <a:prstDash val="solid"/>
+                      <a:round/>
+                      <a:headEnd type="none" w="med" len="med"/>
+                      <a:tailEnd type="none" w="med" len="med"/>
+                    </a:lnB>
+                    <a:solidFill>
+                      <a:srgbClr val="F7FBFA"/>
+                    </a:solidFill>
+                  </a:tcPr>
+                </a:tc>
+                <a:tc>
+                  <a:txBody>
+                    <a:bodyPr/>
+                    <a:lstStyle/>
+                    <a:p>
+                      <a:pPr algn="l" indent="0" marL="0">
+                        <a:buNone/>
+                      </a:pPr>
+                      <a:r>
+                        <a:rPr lang="en-US" sz="1100" dirty="0">
+                          <a:solidFill>
+                            <a:srgbClr val="0B1F49"/>
+                          </a:solidFill>
+                        </a:rPr>
+                        <a:t>~49 k/mois</a:t>
+                      </a:r>
+                      <a:endParaRPr lang="en-US" sz="1100" dirty="0"/>
+                    </a:p>
+                  </a:txBody>
+                  <a:tcPr marL="91440" marR="91440" marT="45720" marB="45720" anchor="ctr">
+                    <a:lnL w="12700" cap="flat" cmpd="sng" algn="ctr">
+                      <a:solidFill>
+                        <a:srgbClr val="E6EEF2"/>
+                      </a:solidFill>
+                      <a:prstDash val="solid"/>
+                      <a:round/>
+                      <a:headEnd type="none" w="med" len="med"/>
+                      <a:tailEnd type="none" w="med" len="med"/>
+                    </a:lnL>
+                    <a:lnR w="12700" cap="flat" cmpd="sng" algn="ctr">
+                      <a:solidFill>
+                        <a:srgbClr val="E6EEF2"/>
+                      </a:solidFill>
+                      <a:prstDash val="solid"/>
+                      <a:round/>
+                      <a:headEnd type="none" w="med" len="med"/>
+                      <a:tailEnd type="none" w="med" len="med"/>
+                    </a:lnR>
+                    <a:lnT w="12700" cap="flat" cmpd="sng" algn="ctr">
+                      <a:solidFill>
+                        <a:srgbClr val="E6EEF2"/>
+                      </a:solidFill>
+                      <a:prstDash val="solid"/>
+                      <a:round/>
+                      <a:headEnd type="none" w="med" len="med"/>
+                      <a:tailEnd type="none" w="med" len="med"/>
+                    </a:lnT>
+                    <a:lnB w="12700" cap="flat" cmpd="sng" algn="ctr">
+                      <a:solidFill>
+                        <a:srgbClr val="E6EEF2"/>
+                      </a:solidFill>
+                      <a:prstDash val="solid"/>
+                      <a:round/>
+                      <a:headEnd type="none" w="med" len="med"/>
+                      <a:tailEnd type="none" w="med" len="med"/>
+                    </a:lnB>
+                    <a:solidFill>
+                      <a:srgbClr val="F7FBFA"/>
+                    </a:solidFill>
+                  </a:tcPr>
+                </a:tc>
+                <a:tc>
+                  <a:txBody>
+                    <a:bodyPr/>
+                    <a:lstStyle/>
+                    <a:p>
+                      <a:pPr algn="l" indent="0" marL="0">
+                        <a:buNone/>
+                      </a:pPr>
+                      <a:r>
+                        <a:rPr lang="en-US" sz="1100" dirty="0">
+                          <a:solidFill>
+                            <a:srgbClr val="0B1F49"/>
+                          </a:solidFill>
+                        </a:rPr>
+                        <a:t>Convention (devis)</a:t>
+                      </a:r>
+                      <a:endParaRPr lang="en-US" sz="1100" dirty="0"/>
+                    </a:p>
+                  </a:txBody>
+                  <a:tcPr marL="91440" marR="91440" marT="45720" marB="45720" anchor="ctr">
+                    <a:lnL w="12700" cap="flat" cmpd="sng" algn="ctr">
+                      <a:solidFill>
+                        <a:srgbClr val="E6EEF2"/>
+                      </a:solidFill>
+                      <a:prstDash val="solid"/>
+                      <a:round/>
+                      <a:headEnd type="none" w="med" len="med"/>
+                      <a:tailEnd type="none" w="med" len="med"/>
+                    </a:lnL>
+                    <a:lnR w="12700" cap="flat" cmpd="sng" algn="ctr">
+                      <a:solidFill>
+                        <a:srgbClr val="E6EEF2"/>
+                      </a:solidFill>
+                      <a:prstDash val="solid"/>
+                      <a:round/>
+                      <a:headEnd type="none" w="med" len="med"/>
+                      <a:tailEnd type="none" w="med" len="med"/>
+                    </a:lnR>
+                    <a:lnT w="12700" cap="flat" cmpd="sng" algn="ctr">
+                      <a:solidFill>
+                        <a:srgbClr val="E6EEF2"/>
+                      </a:solidFill>
+                      <a:prstDash val="solid"/>
+                      <a:round/>
+                      <a:headEnd type="none" w="med" len="med"/>
+                      <a:tailEnd type="none" w="med" len="med"/>
+                    </a:lnT>
+                    <a:lnB w="12700" cap="flat" cmpd="sng" algn="ctr">
+                      <a:solidFill>
+                        <a:srgbClr val="E6EEF2"/>
+                      </a:solidFill>
+                      <a:prstDash val="solid"/>
+                      <a:round/>
+                      <a:headEnd type="none" w="med" len="med"/>
+                      <a:tailEnd type="none" w="med" len="med"/>
+                    </a:lnB>
+                    <a:solidFill>
+                      <a:srgbClr val="F7FBFA"/>
+                    </a:solidFill>
+                  </a:tcPr>
+                </a:tc>
+                <a:tc>
+                  <a:txBody>
+                    <a:bodyPr/>
+                    <a:lstStyle/>
+                    <a:p>
+                      <a:pPr algn="l" indent="0" marL="0">
+                        <a:buNone/>
+                      </a:pPr>
+                      <a:r>
+                        <a:rPr lang="en-US" sz="1100" dirty="0">
+                          <a:solidFill>
+                            <a:srgbClr val="0B1F49"/>
+                          </a:solidFill>
+                        </a:rPr>
+                        <a:t>élevé</a:t>
+                      </a:r>
+                      <a:endParaRPr lang="en-US" sz="1100" dirty="0"/>
+                    </a:p>
+                  </a:txBody>
+                  <a:tcPr marL="91440" marR="91440" marT="45720" marB="45720" anchor="ctr">
+                    <a:lnL w="12700" cap="flat" cmpd="sng" algn="ctr">
+                      <a:solidFill>
+                        <a:srgbClr val="E6EEF2"/>
+                      </a:solidFill>
+                      <a:prstDash val="solid"/>
+                      <a:round/>
+                      <a:headEnd type="none" w="med" len="med"/>
+                      <a:tailEnd type="none" w="med" len="med"/>
+                    </a:lnL>
+                    <a:lnR w="12700" cap="flat" cmpd="sng" algn="ctr">
+                      <a:solidFill>
+                        <a:srgbClr val="E6EEF2"/>
+                      </a:solidFill>
+                      <a:prstDash val="solid"/>
+                      <a:round/>
+                      <a:headEnd type="none" w="med" len="med"/>
+                      <a:tailEnd type="none" w="med" len="med"/>
+                    </a:lnR>
+                    <a:lnT w="12700" cap="flat" cmpd="sng" algn="ctr">
+                      <a:solidFill>
+                        <a:srgbClr val="E6EEF2"/>
+                      </a:solidFill>
+                      <a:prstDash val="solid"/>
+                      <a:round/>
+                      <a:headEnd type="none" w="med" len="med"/>
+                      <a:tailEnd type="none" w="med" len="med"/>
+                    </a:lnT>
+                    <a:lnB w="12700" cap="flat" cmpd="sng" algn="ctr">
+                      <a:solidFill>
+                        <a:srgbClr val="E6EEF2"/>
+                      </a:solidFill>
+                      <a:prstDash val="solid"/>
+                      <a:round/>
+                      <a:headEnd type="none" w="med" len="med"/>
+                      <a:tailEnd type="none" w="med" len="med"/>
+                    </a:lnB>
+                    <a:solidFill>
+                      <a:srgbClr val="F7FBFA"/>
+                    </a:solidFill>
+                  </a:tcPr>
+                </a:tc>
+                <a:tc>
+                  <a:txBody>
+                    <a:bodyPr/>
+                    <a:lstStyle/>
+                    <a:p>
+                      <a:pPr algn="l" indent="0" marL="0">
+                        <a:buNone/>
+                      </a:pPr>
+                      <a:r>
+                        <a:rPr lang="en-US" sz="1100" dirty="0">
+                          <a:solidFill>
+                            <a:srgbClr val="0B1F49"/>
+                          </a:solidFill>
+                        </a:rPr>
+                        <a:t>~88 %</a:t>
+                      </a:r>
+                      <a:endParaRPr lang="en-US" sz="1100" dirty="0"/>
+                    </a:p>
+                  </a:txBody>
+                  <a:tcPr marL="91440" marR="91440" marT="45720" marB="45720" anchor="ctr">
+                    <a:lnL w="12700" cap="flat" cmpd="sng" algn="ctr">
+                      <a:solidFill>
+                        <a:srgbClr val="E6EEF2"/>
+                      </a:solidFill>
+                      <a:prstDash val="solid"/>
+                      <a:round/>
+                      <a:headEnd type="none" w="med" len="med"/>
+                      <a:tailEnd type="none" w="med" len="med"/>
+                    </a:lnL>
+                    <a:lnR w="12700" cap="flat" cmpd="sng" algn="ctr">
+                      <a:solidFill>
+                        <a:srgbClr val="E6EEF2"/>
+                      </a:solidFill>
+                      <a:prstDash val="solid"/>
+                      <a:round/>
+                      <a:headEnd type="none" w="med" len="med"/>
+                      <a:tailEnd type="none" w="med" len="med"/>
+                    </a:lnR>
+                    <a:lnT w="12700" cap="flat" cmpd="sng" algn="ctr">
+                      <a:solidFill>
+                        <a:srgbClr val="E6EEF2"/>
+                      </a:solidFill>
+                      <a:prstDash val="solid"/>
+                      <a:round/>
+                      <a:headEnd type="none" w="med" len="med"/>
+                      <a:tailEnd type="none" w="med" len="med"/>
+                    </a:lnT>
+                    <a:lnB w="12700" cap="flat" cmpd="sng" algn="ctr">
+                      <a:solidFill>
+                        <a:srgbClr val="E6EEF2"/>
+                      </a:solidFill>
+                      <a:prstDash val="solid"/>
+                      <a:round/>
+                      <a:headEnd type="none" w="med" len="med"/>
+                      <a:tailEnd type="none" w="med" len="med"/>
+                    </a:lnB>
+                    <a:solidFill>
+                      <a:srgbClr val="F7FBFA"/>
+                    </a:solidFill>
+                  </a:tcPr>
+                </a:tc>
+              </a:tr>
+              <a:tr h="457200">
                 <a:tc>
                   <a:txBody>
                     <a:bodyPr/>
@@ -5082,7 +5471,7 @@
                   </a:tcPr>
                 </a:tc>
               </a:tr>
-              <a:tr h="502920">
+              <a:tr h="457200">
                 <a:tc>
                   <a:txBody>
                     <a:bodyPr/>
@@ -5450,7 +5839,7 @@
                   </a:tcPr>
                 </a:tc>
               </a:tr>
-              <a:tr h="502920">
+              <a:tr h="457200">
                 <a:tc>
                   <a:txBody>
                     <a:bodyPr/>
@@ -5830,7 +6219,7 @@
         </p:nvSpPr>
         <p:spPr>
           <a:xfrm>
-            <a:off x="457200" y="4754880"/>
+            <a:off x="457200" y="4983480"/>
             <a:ext cx="11247120" cy="365760"/>
           </a:xfrm>
           <a:prstGeom prst="rect">
@@ -5866,7 +6255,7 @@
         </p:nvSpPr>
         <p:spPr>
           <a:xfrm>
-            <a:off x="457200" y="5212080"/>
+            <a:off x="457200" y="5440680"/>
             <a:ext cx="11247120" cy="548640"/>
           </a:xfrm>
           <a:prstGeom prst="rect">
@@ -5901,7 +6290,7 @@
                   <a:srgbClr val="0B1F49"/>
                 </a:solidFill>
               </a:rPr>
-              <a:t>3–12 M XOF · ~50–150 structures payantes · marges 85–95 % · récurrence par période payée à l'avance.</a:t>
+              <a:t>3–12 M XOF · ~50–150 structures payantes + espaces partenaires (MRR B2B) · marges 85–95 %.</a:t>
             </a:r>
             <a:endParaRPr lang="en-US" sz="1300" dirty="0"/>
           </a:p>
@@ -6371,7 +6760,7 @@
                   <a:srgbClr val="667085"/>
                 </a:solidFill>
               </a:rPr>
-              <a:t>Abonnements pages (Vérifié/Pro) + featured ; dons récurrents.</a:t>
+              <a:t>Abonnements pages + espaces partenaires (Kit Digital) ; dons récurrents.</a:t>
             </a:r>
             <a:endParaRPr lang="en-US" sz="1200" dirty="0"/>
           </a:p>
@@ -7506,7 +7895,7 @@
                   <a:srgbClr val="667085"/>
                 </a:solidFill>
               </a:rPr>
-              <a:t>Pourboire sur dons, abonnements de pages (MRR), commission billetterie, sponsoring, data B2B.</a:t>
+              <a:t>Pourboire sur dons, abonnements de pages (MRR), espaces partenaires (Kit Digital), commission billetterie, sponsoring, data B2B.</a:t>
             </a:r>
             <a:endParaRPr lang="en-US" sz="1300" dirty="0"/>
           </a:p>
@@ -7841,7 +8230,7 @@
                   <a:srgbClr val="667085"/>
                 </a:solidFill>
               </a:rPr>
-              <a:t>Structures de santé &amp; ordres professionnels</a:t>
+              <a:t>ASSAD &amp; partenaires communautaires / associatifs (pilotes)</a:t>
             </a:r>
             <a:endParaRPr lang="en-US" sz="700" dirty="0"/>
           </a:p>
@@ -7859,7 +8248,7 @@
                   <a:srgbClr val="667085"/>
                 </a:solidFill>
               </a:rPr>
-              <a:t>ONG, fondations, institutions, bailleurs</a:t>
+              <a:t>Structures de santé &amp; ordres professionnels</a:t>
             </a:r>
             <a:endParaRPr lang="en-US" sz="700" dirty="0"/>
           </a:p>
@@ -7877,7 +8266,7 @@
                   <a:srgbClr val="667085"/>
                 </a:solidFill>
               </a:rPr>
-              <a:t>Google Places / OpenStreetMap (annuaire &amp; carte)</a:t>
+              <a:t>ONG, fondations, institutions &amp; bailleurs</a:t>
             </a:r>
             <a:endParaRPr lang="en-US" sz="700" dirty="0"/>
           </a:p>
@@ -7895,7 +8284,7 @@
                   <a:srgbClr val="667085"/>
                 </a:solidFill>
               </a:rPr>
-              <a:t>Chatwoot / Brevo (support &amp; email)</a:t>
+              <a:t>Partenaires académiques &amp; de formation</a:t>
             </a:r>
             <a:endParaRPr lang="en-US" sz="700" dirty="0"/>
           </a:p>
@@ -7913,7 +8302,7 @@
                   <a:srgbClr val="667085"/>
                 </a:solidFill>
               </a:rPr>
-              <a:t>Firebase / Google Cloud (infrastructure)</a:t>
+              <a:t>Google Places / OSM · Chatwoot / Brevo · Firebase</a:t>
             </a:r>
             <a:endParaRPr lang="en-US" sz="700" dirty="0"/>
           </a:p>
@@ -8088,7 +8477,7 @@
                   <a:srgbClr val="667085"/>
                 </a:solidFill>
               </a:rPr>
-              <a:t>Acquisition / SEO / growth</a:t>
+              <a:t>Onboarding &amp; animation des espaces partenaires</a:t>
             </a:r>
             <a:endParaRPr lang="en-US" sz="700" dirty="0"/>
           </a:p>
@@ -8106,7 +8495,7 @@
                   <a:srgbClr val="667085"/>
                 </a:solidFill>
               </a:rPr>
-              <a:t>Vente B2B (structures, partenaires)</a:t>
+              <a:t>Campagnes de prévention ciblées (SMS / WhatsApp)</a:t>
             </a:r>
             <a:endParaRPr lang="en-US" sz="700" dirty="0"/>
           </a:p>
@@ -8124,7 +8513,25 @@
                   <a:srgbClr val="667085"/>
                 </a:solidFill>
               </a:rPr>
-              <a:t>Traitement des paiements &amp; reversements</a:t>
+              <a:t>Mesure d'impact &amp; reporting ESG</a:t>
+            </a:r>
+            <a:endParaRPr lang="en-US" sz="700" dirty="0"/>
+          </a:p>
+          <a:p>
+            <a:pPr marL="152400" indent="-152400">
+              <a:lnSpc>
+                <a:spcPct val="95000"/>
+              </a:lnSpc>
+              <a:buSzPct val="100000"/>
+              <a:buChar char="•"/>
+            </a:pPr>
+            <a:r>
+              <a:rPr lang="en-US" sz="700" dirty="0">
+                <a:solidFill>
+                  <a:srgbClr val="667085"/>
+                </a:solidFill>
+              </a:rPr>
+              <a:t>Acquisition / SEO / growth · vente B2B · paiements</a:t>
             </a:r>
             <a:endParaRPr lang="en-US" sz="700" dirty="0"/>
           </a:p>
@@ -8281,7 +8688,7 @@
                   <a:srgbClr val="667085"/>
                 </a:solidFill>
               </a:rPr>
-              <a:t>Annuaire des structures (effet réseau)</a:t>
+              <a:t>Socle multi-tenant + Comités (gouvernance d'impact)</a:t>
             </a:r>
             <a:endParaRPr lang="en-US" sz="700" dirty="0"/>
           </a:p>
@@ -8299,7 +8706,7 @@
                   <a:srgbClr val="667085"/>
                 </a:solidFill>
               </a:rPr>
-              <a:t>Audience &amp; communauté engagée</a:t>
+              <a:t>Annuaire des structures + catalogue de formations (réseau)</a:t>
             </a:r>
             <a:endParaRPr lang="en-US" sz="700" dirty="0"/>
           </a:p>
@@ -8317,7 +8724,7 @@
                   <a:srgbClr val="667085"/>
                 </a:solidFill>
               </a:rPr>
-              <a:t>Marque de confiance + comité éditorial</a:t>
+              <a:t>Audience &amp; communauté engagée · marque de confiance</a:t>
             </a:r>
             <a:endParaRPr lang="en-US" sz="700" dirty="0"/>
           </a:p>
@@ -8335,7 +8742,7 @@
                   <a:srgbClr val="667085"/>
                 </a:solidFill>
               </a:rPr>
-              <a:t>Intégration mobile money (Bictorys)</a:t>
+              <a:t>Mobile money (Bictorys) + omnicanal (Chatwoot)</a:t>
             </a:r>
             <a:endParaRPr lang="en-US" sz="700" dirty="0"/>
           </a:p>
@@ -8492,7 +8899,7 @@
                   <a:srgbClr val="667085"/>
                 </a:solidFill>
               </a:rPr>
-              <a:t>Collecte de fonds traçable pour équipements (impact mesurable)</a:t>
+              <a:t>Espaces partenaires en marque blanche (Kit Digital)</a:t>
             </a:r>
             <a:endParaRPr lang="en-US" sz="700" dirty="0"/>
           </a:p>
@@ -8510,7 +8917,7 @@
                   <a:srgbClr val="667085"/>
                 </a:solidFill>
               </a:rPr>
-              <a:t>Communauté &amp; forum de confiance (rôles soignants)</a:t>
+              <a:t>Campagnes de prévention SMS/WhatsApp ciblées (consenties)</a:t>
             </a:r>
             <a:endParaRPr lang="en-US" sz="700" dirty="0"/>
           </a:p>
@@ -8528,7 +8935,7 @@
                   <a:srgbClr val="667085"/>
                 </a:solidFill>
               </a:rPr>
-              <a:t>Billetterie d'événements santé</a:t>
+              <a:t>Tableaux de bord d'impact + reporting ESG (Comités)</a:t>
             </a:r>
             <a:endParaRPr lang="en-US" sz="700" dirty="0"/>
           </a:p>
@@ -8546,7 +8953,25 @@
                   <a:srgbClr val="667085"/>
                 </a:solidFill>
               </a:rPr>
-              <a:t>Partenaires : visibilité ciblée + data d'impact</a:t>
+              <a:t>Collecte de fonds traçable + billetterie d'événements</a:t>
+            </a:r>
+            <a:endParaRPr lang="en-US" sz="700" dirty="0"/>
+          </a:p>
+          <a:p>
+            <a:pPr marL="152400" indent="-152400">
+              <a:lnSpc>
+                <a:spcPct val="95000"/>
+              </a:lnSpc>
+              <a:buSzPct val="100000"/>
+              <a:buChar char="•"/>
+            </a:pPr>
+            <a:r>
+              <a:rPr lang="en-US" sz="700" dirty="0">
+                <a:solidFill>
+                  <a:srgbClr val="667085"/>
+                </a:solidFill>
+              </a:rPr>
+              <a:t>Communauté &amp; annuaire de professionnels vérifiés · formations</a:t>
             </a:r>
             <a:endParaRPr lang="en-US" sz="700" dirty="0"/>
           </a:p>
@@ -8685,7 +9110,7 @@
                   <a:srgbClr val="667085"/>
                 </a:solidFill>
               </a:rPr>
-              <a:t>Communauté &amp; forum modérés</a:t>
+              <a:t>Espace partenaire dédié + Comité de pilotage</a:t>
             </a:r>
             <a:endParaRPr lang="en-US" sz="700" dirty="0"/>
           </a:p>
@@ -8703,7 +9128,7 @@
                   <a:srgbClr val="667085"/>
                 </a:solidFill>
               </a:rPr>
-              <a:t>Support (Chatwoot + messagerie in-app)</a:t>
+              <a:t>Reconnaissance des donateurs (« Mes dons &amp; impact »)</a:t>
             </a:r>
             <a:endParaRPr lang="en-US" sz="700" dirty="0"/>
           </a:p>
@@ -8721,7 +9146,7 @@
                   <a:srgbClr val="667085"/>
                 </a:solidFill>
               </a:rPr>
-              <a:t>Contenu éditorial régulier (confiance)</a:t>
+              <a:t>Communauté &amp; forum modérés</a:t>
             </a:r>
             <a:endParaRPr lang="en-US" sz="700" dirty="0"/>
           </a:p>
@@ -8739,7 +9164,25 @@
                   <a:srgbClr val="667085"/>
                 </a:solidFill>
               </a:rPr>
-              <a:t>Abonnements (relation récurrente structures)</a:t>
+              <a:t>Support omnicanal (Chatwoot + messagerie in-app)</a:t>
+            </a:r>
+            <a:endParaRPr lang="en-US" sz="700" dirty="0"/>
+          </a:p>
+          <a:p>
+            <a:pPr marL="152400" indent="-152400">
+              <a:lnSpc>
+                <a:spcPct val="95000"/>
+              </a:lnSpc>
+              <a:buSzPct val="100000"/>
+              <a:buChar char="•"/>
+            </a:pPr>
+            <a:r>
+              <a:rPr lang="en-US" sz="700" dirty="0">
+                <a:solidFill>
+                  <a:srgbClr val="667085"/>
+                </a:solidFill>
+              </a:rPr>
+              <a:t>Abonnements (relation récurrente structures &amp; partenaires)</a:t>
             </a:r>
             <a:endParaRPr lang="en-US" sz="700" dirty="0"/>
           </a:p>
@@ -8878,7 +9321,7 @@
                   <a:srgbClr val="667085"/>
                 </a:solidFill>
               </a:rPr>
-              <a:t>Recherche fédérée (Typesense)</a:t>
+              <a:t>Sous-domaines partenaires (&lt;marque&gt;.werguyaram.org)</a:t>
             </a:r>
             <a:endParaRPr lang="en-US" sz="700" dirty="0"/>
           </a:p>
@@ -8896,7 +9339,7 @@
                   <a:srgbClr val="667085"/>
                 </a:solidFill>
               </a:rPr>
-              <a:t>Réseaux sociaux &amp; partage de campagnes</a:t>
+              <a:t>Campagnes SMS / WhatsApp (Chatwoot)</a:t>
             </a:r>
             <a:endParaRPr lang="en-US" sz="700" dirty="0"/>
           </a:p>
@@ -8914,7 +9357,7 @@
                   <a:srgbClr val="667085"/>
                 </a:solidFill>
               </a:rPr>
-              <a:t>Communautés WhatsApp / églises (canal local)</a:t>
+              <a:t>Recherche fédérée (Typesense)</a:t>
             </a:r>
             <a:endParaRPr lang="en-US" sz="700" dirty="0"/>
           </a:p>
@@ -8932,7 +9375,7 @@
                   <a:srgbClr val="667085"/>
                 </a:solidFill>
               </a:rPr>
-              <a:t>Newsletter / email</a:t>
+              <a:t>Réseaux sociaux · communautés WhatsApp / églises</a:t>
             </a:r>
             <a:endParaRPr lang="en-US" sz="700" dirty="0"/>
           </a:p>
@@ -8950,7 +9393,7 @@
                   <a:srgbClr val="667085"/>
                 </a:solidFill>
               </a:rPr>
-              <a:t>Bouche-à-oreille &amp; parrainage</a:t>
+              <a:t>Newsletter / email · bouche-à-oreille &amp; parrainage</a:t>
             </a:r>
             <a:endParaRPr lang="en-US" sz="700" dirty="0"/>
           </a:p>
@@ -9125,7 +9568,7 @@
                   <a:srgbClr val="667085"/>
                 </a:solidFill>
               </a:rPr>
-              <a:t>Partenaires / ONG / institutions / bailleurs</a:t>
+              <a:t>Partenaires communautaires &amp; associatifs (ASSAD)</a:t>
             </a:r>
             <a:endParaRPr lang="en-US" sz="700" dirty="0"/>
           </a:p>
@@ -9143,7 +9586,7 @@
                   <a:srgbClr val="667085"/>
                 </a:solidFill>
               </a:rPr>
-              <a:t>Organisateurs d'événements santé</a:t>
+              <a:t>Institutions &amp; bailleurs (impact / ESG)</a:t>
             </a:r>
             <a:endParaRPr lang="en-US" sz="700" dirty="0"/>
           </a:p>
@@ -9161,7 +9604,7 @@
                   <a:srgbClr val="667085"/>
                 </a:solidFill>
               </a:rPr>
-              <a:t>Soignants (forum, contenu)</a:t>
+              <a:t>Académiques &amp; formation · soignants vérifiés · organisateurs</a:t>
             </a:r>
             <a:endParaRPr lang="en-US" sz="700" dirty="0"/>
           </a:p>
@@ -9318,7 +9761,7 @@
                   <a:srgbClr val="667085"/>
                 </a:solidFill>
               </a:rPr>
-              <a:t>Production éditoriale &amp; modération</a:t>
+              <a:t>Coûts SMS / WhatsApp (templates Meta, agrégateur)</a:t>
             </a:r>
             <a:endParaRPr lang="en-US" sz="700" dirty="0"/>
           </a:p>
@@ -9439,7 +9882,7 @@
                   <a:srgbClr val="667085"/>
                 </a:solidFill>
               </a:rPr>
-              <a:t>Dons + pourboire plateforme optionnel (+ récurrents)</a:t>
+              <a:t>Dons + pourboire plateforme optionnel (+ dons récurrents)</a:t>
             </a:r>
             <a:endParaRPr lang="en-US" sz="700" dirty="0"/>
           </a:p>
@@ -9475,7 +9918,7 @@
                   <a:srgbClr val="667085"/>
                 </a:solidFill>
               </a:rPr>
-              <a:t>Commission billetterie (8–10 %)</a:t>
+              <a:t>Espaces partenaires (Kit Digital) : ~49–99 k XOF/mois + Pacte-Convention annuel sur devis</a:t>
             </a:r>
             <a:endParaRPr lang="en-US" sz="700" dirty="0"/>
           </a:p>
@@ -9773,7 +10216,7 @@
                   <a:srgbClr val="0B1F49"/>
                 </a:solidFill>
               </a:rPr>
-              <a:t>Structures de santé &amp; ordres professionnels</a:t>
+              <a:t>ASSAD &amp; partenaires communautaires / associatifs (pilotes)</a:t>
             </a:r>
             <a:endParaRPr lang="en-US" sz="1600" dirty="0"/>
           </a:p>
@@ -9794,7 +10237,7 @@
                   <a:srgbClr val="0B1F49"/>
                 </a:solidFill>
               </a:rPr>
-              <a:t>ONG, fondations, institutions, bailleurs</a:t>
+              <a:t>Structures de santé &amp; ordres professionnels</a:t>
             </a:r>
             <a:endParaRPr lang="en-US" sz="1600" dirty="0"/>
           </a:p>
@@ -9815,7 +10258,7 @@
                   <a:srgbClr val="0B1F49"/>
                 </a:solidFill>
               </a:rPr>
-              <a:t>Google Places / OpenStreetMap (annuaire &amp; carte)</a:t>
+              <a:t>ONG, fondations, institutions &amp; bailleurs</a:t>
             </a:r>
             <a:endParaRPr lang="en-US" sz="1600" dirty="0"/>
           </a:p>
@@ -9836,7 +10279,7 @@
                   <a:srgbClr val="0B1F49"/>
                 </a:solidFill>
               </a:rPr>
-              <a:t>Chatwoot / Brevo (support &amp; email)</a:t>
+              <a:t>Partenaires académiques &amp; de formation</a:t>
             </a:r>
             <a:endParaRPr lang="en-US" sz="1600" dirty="0"/>
           </a:p>
@@ -9857,7 +10300,7 @@
                   <a:srgbClr val="0B1F49"/>
                 </a:solidFill>
               </a:rPr>
-              <a:t>Firebase / Google Cloud (infrastructure)</a:t>
+              <a:t>Google Places / OSM · Chatwoot / Brevo · Firebase</a:t>
             </a:r>
             <a:endParaRPr lang="en-US" sz="1600" dirty="0"/>
           </a:p>
@@ -10197,7 +10640,7 @@
                   <a:srgbClr val="0B1F49"/>
                 </a:solidFill>
               </a:rPr>
-              <a:t>Acquisition / SEO / growth</a:t>
+              <a:t>Onboarding &amp; animation des espaces partenaires</a:t>
             </a:r>
             <a:endParaRPr lang="en-US" sz="1600" dirty="0"/>
           </a:p>
@@ -10218,7 +10661,7 @@
                   <a:srgbClr val="0B1F49"/>
                 </a:solidFill>
               </a:rPr>
-              <a:t>Vente B2B (structures, partenaires)</a:t>
+              <a:t>Campagnes de prévention ciblées (SMS / WhatsApp)</a:t>
             </a:r>
             <a:endParaRPr lang="en-US" sz="1600" dirty="0"/>
           </a:p>
@@ -10239,7 +10682,28 @@
                   <a:srgbClr val="0B1F49"/>
                 </a:solidFill>
               </a:rPr>
-              <a:t>Traitement des paiements &amp; reversements</a:t>
+              <a:t>Mesure d'impact &amp; reporting ESG</a:t>
+            </a:r>
+            <a:endParaRPr lang="en-US" sz="1600" dirty="0"/>
+          </a:p>
+          <a:p>
+            <a:pPr marL="152400" indent="-152400">
+              <a:lnSpc>
+                <a:spcPct val="110000"/>
+              </a:lnSpc>
+              <a:spcAft>
+                <a:spcPts val="1000"/>
+              </a:spcAft>
+              <a:buSzPct val="100000"/>
+              <a:buChar char="•"/>
+            </a:pPr>
+            <a:r>
+              <a:rPr lang="en-US" sz="1600" dirty="0">
+                <a:solidFill>
+                  <a:srgbClr val="0B1F49"/>
+                </a:solidFill>
+              </a:rPr>
+              <a:t>Acquisition / SEO / growth · vente B2B · paiements</a:t>
             </a:r>
             <a:endParaRPr lang="en-US" sz="1600" dirty="0"/>
           </a:p>
@@ -10558,7 +11022,7 @@
                   <a:srgbClr val="0B1F49"/>
                 </a:solidFill>
               </a:rPr>
-              <a:t>Annuaire des structures (effet réseau)</a:t>
+              <a:t>Socle multi-tenant + Comités (gouvernance d'impact)</a:t>
             </a:r>
             <a:endParaRPr lang="en-US" sz="1600" dirty="0"/>
           </a:p>
@@ -10579,7 +11043,7 @@
                   <a:srgbClr val="0B1F49"/>
                 </a:solidFill>
               </a:rPr>
-              <a:t>Audience &amp; communauté engagée</a:t>
+              <a:t>Annuaire des structures + catalogue de formations (réseau)</a:t>
             </a:r>
             <a:endParaRPr lang="en-US" sz="1600" dirty="0"/>
           </a:p>
@@ -10600,7 +11064,7 @@
                   <a:srgbClr val="0B1F49"/>
                 </a:solidFill>
               </a:rPr>
-              <a:t>Marque de confiance + comité éditorial</a:t>
+              <a:t>Audience &amp; communauté engagée · marque de confiance</a:t>
             </a:r>
             <a:endParaRPr lang="en-US" sz="1600" dirty="0"/>
           </a:p>
@@ -10621,7 +11085,7 @@
                   <a:srgbClr val="0B1F49"/>
                 </a:solidFill>
               </a:rPr>
-              <a:t>Intégration mobile money (Bictorys)</a:t>
+              <a:t>Mobile money (Bictorys) + omnicanal (Chatwoot)</a:t>
             </a:r>
             <a:endParaRPr lang="en-US" sz="1600" dirty="0"/>
           </a:p>
@@ -10940,7 +11404,7 @@
                   <a:srgbClr val="0B1F49"/>
                 </a:solidFill>
               </a:rPr>
-              <a:t>Collecte de fonds traçable pour équipements (impact mesurable)</a:t>
+              <a:t>Espaces partenaires en marque blanche (Kit Digital)</a:t>
             </a:r>
             <a:endParaRPr lang="en-US" sz="1600" dirty="0"/>
           </a:p>
@@ -10961,7 +11425,7 @@
                   <a:srgbClr val="0B1F49"/>
                 </a:solidFill>
               </a:rPr>
-              <a:t>Communauté &amp; forum de confiance (rôles soignants)</a:t>
+              <a:t>Campagnes de prévention SMS/WhatsApp ciblées (consenties)</a:t>
             </a:r>
             <a:endParaRPr lang="en-US" sz="1600" dirty="0"/>
           </a:p>
@@ -10982,7 +11446,7 @@
                   <a:srgbClr val="0B1F49"/>
                 </a:solidFill>
               </a:rPr>
-              <a:t>Billetterie d'événements santé</a:t>
+              <a:t>Tableaux de bord d'impact + reporting ESG (Comités)</a:t>
             </a:r>
             <a:endParaRPr lang="en-US" sz="1600" dirty="0"/>
           </a:p>
@@ -11003,7 +11467,28 @@
                   <a:srgbClr val="0B1F49"/>
                 </a:solidFill>
               </a:rPr>
-              <a:t>Partenaires : visibilité ciblée + data d'impact</a:t>
+              <a:t>Collecte de fonds traçable + billetterie d'événements</a:t>
+            </a:r>
+            <a:endParaRPr lang="en-US" sz="1600" dirty="0"/>
+          </a:p>
+          <a:p>
+            <a:pPr marL="152400" indent="-152400">
+              <a:lnSpc>
+                <a:spcPct val="110000"/>
+              </a:lnSpc>
+              <a:spcAft>
+                <a:spcPts val="1000"/>
+              </a:spcAft>
+              <a:buSzPct val="100000"/>
+              <a:buChar char="•"/>
+            </a:pPr>
+            <a:r>
+              <a:rPr lang="en-US" sz="1600" dirty="0">
+                <a:solidFill>
+                  <a:srgbClr val="0B1F49"/>
+                </a:solidFill>
+              </a:rPr>
+              <a:t>Communauté &amp; annuaire de professionnels vérifiés · formations</a:t>
             </a:r>
             <a:endParaRPr lang="en-US" sz="1600" dirty="0"/>
           </a:p>
@@ -11301,7 +11786,7 @@
                   <a:srgbClr val="0B1F49"/>
                 </a:solidFill>
               </a:rPr>
-              <a:t>Communauté &amp; forum modérés</a:t>
+              <a:t>Espace partenaire dédié + Comité de pilotage</a:t>
             </a:r>
             <a:endParaRPr lang="en-US" sz="1600" dirty="0"/>
           </a:p>
@@ -11322,7 +11807,7 @@
                   <a:srgbClr val="0B1F49"/>
                 </a:solidFill>
               </a:rPr>
-              <a:t>Support (Chatwoot + messagerie in-app)</a:t>
+              <a:t>Reconnaissance des donateurs (« Mes dons &amp; impact »)</a:t>
             </a:r>
             <a:endParaRPr lang="en-US" sz="1600" dirty="0"/>
           </a:p>
@@ -11343,7 +11828,7 @@
                   <a:srgbClr val="0B1F49"/>
                 </a:solidFill>
               </a:rPr>
-              <a:t>Contenu éditorial régulier (confiance)</a:t>
+              <a:t>Communauté &amp; forum modérés</a:t>
             </a:r>
             <a:endParaRPr lang="en-US" sz="1600" dirty="0"/>
           </a:p>
@@ -11364,7 +11849,28 @@
                   <a:srgbClr val="0B1F49"/>
                 </a:solidFill>
               </a:rPr>
-              <a:t>Abonnements (relation récurrente structures)</a:t>
+              <a:t>Support omnicanal (Chatwoot + messagerie in-app)</a:t>
+            </a:r>
+            <a:endParaRPr lang="en-US" sz="1600" dirty="0"/>
+          </a:p>
+          <a:p>
+            <a:pPr marL="152400" indent="-152400">
+              <a:lnSpc>
+                <a:spcPct val="110000"/>
+              </a:lnSpc>
+              <a:spcAft>
+                <a:spcPts val="1000"/>
+              </a:spcAft>
+              <a:buSzPct val="100000"/>
+              <a:buChar char="•"/>
+            </a:pPr>
+            <a:r>
+              <a:rPr lang="en-US" sz="1600" dirty="0">
+                <a:solidFill>
+                  <a:srgbClr val="0B1F49"/>
+                </a:solidFill>
+              </a:rPr>
+              <a:t>Abonnements (relation récurrente structures &amp; partenaires)</a:t>
             </a:r>
             <a:endParaRPr lang="en-US" sz="1600" dirty="0"/>
           </a:p>
@@ -11662,7 +12168,7 @@
                   <a:srgbClr val="0B1F49"/>
                 </a:solidFill>
               </a:rPr>
-              <a:t>Recherche fédérée (Typesense)</a:t>
+              <a:t>Sous-domaines partenaires (&lt;marque&gt;.werguyaram.org)</a:t>
             </a:r>
             <a:endParaRPr lang="en-US" sz="1600" dirty="0"/>
           </a:p>
@@ -11683,7 +12189,7 @@
                   <a:srgbClr val="0B1F49"/>
                 </a:solidFill>
               </a:rPr>
-              <a:t>Réseaux sociaux &amp; partage de campagnes</a:t>
+              <a:t>Campagnes SMS / WhatsApp (Chatwoot)</a:t>
             </a:r>
             <a:endParaRPr lang="en-US" sz="1600" dirty="0"/>
           </a:p>
@@ -11704,7 +12210,7 @@
                   <a:srgbClr val="0B1F49"/>
                 </a:solidFill>
               </a:rPr>
-              <a:t>Communautés WhatsApp / églises (canal local)</a:t>
+              <a:t>Recherche fédérée (Typesense)</a:t>
             </a:r>
             <a:endParaRPr lang="en-US" sz="1600" dirty="0"/>
           </a:p>
@@ -11725,7 +12231,7 @@
                   <a:srgbClr val="0B1F49"/>
                 </a:solidFill>
               </a:rPr>
-              <a:t>Newsletter / email</a:t>
+              <a:t>Réseaux sociaux · communautés WhatsApp / églises</a:t>
             </a:r>
             <a:endParaRPr lang="en-US" sz="1600" dirty="0"/>
           </a:p>
@@ -11746,7 +12252,7 @@
                   <a:srgbClr val="0B1F49"/>
                 </a:solidFill>
               </a:rPr>
-              <a:t>Bouche-à-oreille &amp; parrainage</a:t>
+              <a:t>Newsletter / email · bouche-à-oreille &amp; parrainage</a:t>
             </a:r>
             <a:endParaRPr lang="en-US" sz="1600" dirty="0"/>
           </a:p>

</xml_diff>